<commit_message>
docs(defense): explain AP at first use in slides and speech
</commit_message>
<xml_diff>
--- a/bao-ve/Bao-cao-chuyen-de-10-slide-v4.pptx
+++ b/bao-ve/Bao-cao-chuyen-de-10-slide-v4.pptx
@@ -9092,7 +9092,7 @@
               </a:defRPr>
             </a:pPr>
             <a:r>
-              <a:t>Mục tiêu học tự giám sát được tính trong mã; loss không phải AP phát hiện</a:t>
+              <a:t>Mục tiêu học tự giám sát được tính trong mã; loss không phải điểm phát hiện</a:t>
             </a:r>
           </a:p>
         </p:txBody>
@@ -10298,7 +10298,7 @@
               </a:defRPr>
             </a:pPr>
             <a:r>
-              <a:t>Trọng số 1 / 1 / 0,1 là hệ số tối ưu hóa, không phải tỷ lệ đóng góp vào AP.</a:t>
+              <a:t>Trọng số 1 / 1 / 0,1 là hệ số tối ưu hóa, không phải tỷ lệ đóng góp vào kết quả phát hiện.</a:t>
             </a:r>
           </a:p>
         </p:txBody>
@@ -10894,8 +10894,8 @@
         </p:nvSpPr>
         <p:spPr>
           <a:xfrm>
-            <a:off x="694944" y="4462272"/>
-            <a:ext cx="3310128" cy="914400"/>
+            <a:off x="694944" y="4343400"/>
+            <a:ext cx="3310128" cy="1161288"/>
           </a:xfrm>
           <a:prstGeom prst="rect">
             <a:avLst/>
@@ -10942,7 +10942,8 @@
               </a:defRPr>
             </a:pPr>
             <a:r>
-              <a:t>AP và ROC-AUC đo trên Validation.</a:t>
+              <a:rPr sz="1230"/>
+              <a:t>AP = Average Precision: xếp hạng lớp dương.</a:t>
             </a:r>
           </a:p>
           <a:p>
@@ -10961,7 +10962,8 @@
               </a:defRPr>
             </a:pPr>
             <a:r>
-              <a:t>Backbone optimizer steps = 0.</a:t>
+              <a:rPr sz="1230"/>
+              <a:t>ROC-AUC: phân biệt hai lớp qua nhiều ngưỡng; backbone 0 bước cập nhật.</a:t>
             </a:r>
           </a:p>
         </p:txBody>
@@ -10974,7 +10976,7 @@
         </p:nvSpPr>
         <p:spPr>
           <a:xfrm>
-            <a:off x="694944" y="5468112"/>
+            <a:off x="694944" y="5559552"/>
             <a:ext cx="3310128" cy="228600"/>
           </a:xfrm>
           <a:prstGeom prst="rect">

</xml_diff>

<commit_message>
chore(release): retain presentation and evidence-only package
</commit_message>
<xml_diff>
--- a/bao-ve/Bao-cao-chuyen-de-10-slide-v4.pptx
+++ b/bao-ve/Bao-cao-chuyen-de-10-slide-v4.pptx
@@ -116,6 +116,11 @@
       </a:defRPr>
     </a:lvl9pPr>
   </p:defaultTextStyle>
+  <p:extLst>
+    <p:ext uri="{EFAFB233-063F-42B5-8137-9DF3F51BA10A}">
+      <p15:sldGuideLst xmlns:p15="http://schemas.microsoft.com/office/powerpoint/2012/main"/>
+    </p:ext>
+  </p:extLst>
 </p:presentation>
 </file>
 
@@ -2901,8 +2906,8 @@
           </a:p>
         </p:txBody>
       </p:sp>
-      <mc:AlternateContent xmlns:mc="http://schemas.openxmlformats.org/markup-compatibility/2006">
-        <mc:Choice xmlns:a14="http://schemas.microsoft.com/office/drawing/2010/main" Requires="a14">
+      <mc:AlternateContent xmlns:mc="http://schemas.openxmlformats.org/markup-compatibility/2006" xmlns:a14="http://schemas.microsoft.com/office/drawing/2010/main">
+        <mc:Choice Requires="a14">
           <p:graphicFrame>
             <p:nvGraphicFramePr>
               <p:cNvPr id="8" name="Table 7"/>
@@ -3436,7 +3441,7 @@
             </a:graphic>
           </p:graphicFrame>
         </mc:Choice>
-        <mc:Fallback>
+        <mc:Fallback xmlns="">
           <p:graphicFrame>
             <p:nvGraphicFramePr>
               <p:cNvPr id="8" name="Table 7"/>
@@ -5884,8 +5889,8 @@
           </a:ln>
         </p:spPr>
       </p:sp>
-      <mc:AlternateContent xmlns:mc="http://schemas.openxmlformats.org/markup-compatibility/2006">
-        <mc:Choice xmlns:a14="http://schemas.microsoft.com/office/drawing/2010/main" Requires="a14">
+      <mc:AlternateContent xmlns:mc="http://schemas.openxmlformats.org/markup-compatibility/2006" xmlns:a14="http://schemas.microsoft.com/office/drawing/2010/main">
+        <mc:Choice Requires="a14">
           <p:sp>
             <p:nvSpPr>
               <p:cNvPr id="7" name="central head">
@@ -5965,7 +5970,7 @@
             </p:txBody>
           </p:sp>
         </mc:Choice>
-        <mc:Fallback>
+        <mc:Fallback xmlns="">
           <p:sp>
             <p:nvSpPr>
               <p:cNvPr id="7" name="central head">
@@ -9216,8 +9221,8 @@
           </a:p>
         </p:txBody>
       </p:sp>
-      <mc:AlternateContent xmlns:mc="http://schemas.openxmlformats.org/markup-compatibility/2006">
-        <mc:Choice xmlns:a14="http://schemas.microsoft.com/office/drawing/2010/main" Requires="a14">
+      <mc:AlternateContent xmlns:mc="http://schemas.openxmlformats.org/markup-compatibility/2006" xmlns:a14="http://schemas.microsoft.com/office/drawing/2010/main">
+        <mc:Choice Requires="a14">
           <p:sp>
             <p:nvSpPr>
               <p:cNvPr id="18" name="TextBox 17"/>
@@ -9379,7 +9384,7 @@
             </p:txBody>
           </p:sp>
         </mc:Choice>
-        <mc:Fallback>
+        <mc:Fallback xmlns="">
           <p:sp>
             <p:nvSpPr>
               <p:cNvPr id="18" name="TextBox 17"/>
@@ -10050,8 +10055,8 @@
             </p:nvSpPr>
             <p:spPr>
               <a:xfrm>
-                <a:off x="704088" y="1764792"/>
-                <a:ext cx="4187952" cy="530352"/>
+                <a:off x="676656" y="1834374"/>
+                <a:ext cx="4325112" cy="318036"/>
               </a:xfrm>
               <a:prstGeom prst="rect">
                 <a:avLst/>
@@ -10247,8 +10252,8 @@
             </p:nvSpPr>
             <p:spPr>
               <a:xfrm>
-                <a:off x="704088" y="1764792"/>
-                <a:ext cx="4187952" cy="530352"/>
+                <a:off x="676656" y="1834374"/>
+                <a:ext cx="4325112" cy="318036"/>
               </a:xfrm>
               <a:prstGeom prst="rect">
                 <a:avLst/>
@@ -10256,7 +10261,7 @@
               <a:blipFill>
                 <a:blip r:embed="rId3"/>
                 <a:stretch>
-                  <a:fillRect t="-1149" b="-14943"/>
+                  <a:fillRect l="-1268" r="-563" b="-25000"/>
                 </a:stretch>
               </a:blipFill>
             </p:spPr>
@@ -11615,8 +11620,8 @@
           </a:p>
         </p:txBody>
       </p:sp>
-      <mc:AlternateContent xmlns:mc="http://schemas.openxmlformats.org/markup-compatibility/2006">
-        <mc:Choice xmlns:a14="http://schemas.microsoft.com/office/drawing/2010/main" Requires="a14">
+      <mc:AlternateContent xmlns:mc="http://schemas.openxmlformats.org/markup-compatibility/2006" xmlns:a14="http://schemas.microsoft.com/office/drawing/2010/main">
+        <mc:Choice Requires="a14">
           <p:sp>
             <p:nvSpPr>
               <p:cNvPr id="9" name="TextBox 8"/>
@@ -11851,7 +11856,7 @@
             </p:txBody>
           </p:sp>
         </mc:Choice>
-        <mc:Fallback>
+        <mc:Fallback xmlns="">
           <p:sp>
             <p:nvSpPr>
               <p:cNvPr id="9" name="TextBox 8"/>
@@ -12056,8 +12061,8 @@
           </a:p>
         </p:txBody>
       </p:sp>
-      <mc:AlternateContent xmlns:mc="http://schemas.openxmlformats.org/markup-compatibility/2006">
-        <mc:Choice xmlns:a14="http://schemas.microsoft.com/office/drawing/2010/main" Requires="a14">
+      <mc:AlternateContent xmlns:mc="http://schemas.openxmlformats.org/markup-compatibility/2006" xmlns:a14="http://schemas.microsoft.com/office/drawing/2010/main">
+        <mc:Choice Requires="a14">
           <p:sp>
             <p:nvSpPr>
               <p:cNvPr id="12" name="TextBox 11"/>
@@ -12297,7 +12302,7 @@
             </p:txBody>
           </p:sp>
         </mc:Choice>
-        <mc:Fallback>
+        <mc:Fallback xmlns="">
           <p:sp>
             <p:nvSpPr>
               <p:cNvPr id="12" name="TextBox 11"/>
@@ -12420,8 +12425,8 @@
           </a:p>
         </p:txBody>
       </p:sp>
-      <mc:AlternateContent xmlns:mc="http://schemas.openxmlformats.org/markup-compatibility/2006">
-        <mc:Choice xmlns:a14="http://schemas.microsoft.com/office/drawing/2010/main" Requires="a14">
+      <mc:AlternateContent xmlns:mc="http://schemas.openxmlformats.org/markup-compatibility/2006" xmlns:a14="http://schemas.microsoft.com/office/drawing/2010/main">
+        <mc:Choice Requires="a14">
           <p:graphicFrame>
             <p:nvGraphicFramePr>
               <p:cNvPr id="15" name="Table 14"/>
@@ -13412,7 +13417,7 @@
             </a:graphic>
           </p:graphicFrame>
         </mc:Choice>
-        <mc:Fallback>
+        <mc:Fallback xmlns="">
           <p:graphicFrame>
             <p:nvGraphicFramePr>
               <p:cNvPr id="15" name="Table 14"/>
@@ -14356,8 +14361,8 @@
           </p:graphicFrame>
         </mc:Fallback>
       </mc:AlternateContent>
-      <mc:AlternateContent xmlns:mc="http://schemas.openxmlformats.org/markup-compatibility/2006">
-        <mc:Choice xmlns:a14="http://schemas.microsoft.com/office/drawing/2010/main" Requires="a14">
+      <mc:AlternateContent xmlns:mc="http://schemas.openxmlformats.org/markup-compatibility/2006" xmlns:a14="http://schemas.microsoft.com/office/drawing/2010/main">
+        <mc:Choice Requires="a14">
           <p:sp>
             <p:nvSpPr>
               <p:cNvPr id="16" name="TextBox 15"/>
@@ -14416,7 +14421,7 @@
             </p:txBody>
           </p:sp>
         </mc:Choice>
-        <mc:Fallback>
+        <mc:Fallback xmlns="">
           <p:sp>
             <p:nvSpPr>
               <p:cNvPr id="16" name="TextBox 15"/>
@@ -14793,8 +14798,8 @@
           </a:p>
         </p:txBody>
       </p:sp>
-      <mc:AlternateContent xmlns:mc="http://schemas.openxmlformats.org/markup-compatibility/2006">
-        <mc:Choice xmlns:a14="http://schemas.microsoft.com/office/drawing/2010/main" Requires="a14">
+      <mc:AlternateContent xmlns:mc="http://schemas.openxmlformats.org/markup-compatibility/2006" xmlns:a14="http://schemas.microsoft.com/office/drawing/2010/main">
+        <mc:Choice Requires="a14">
           <p:sp>
             <p:nvSpPr>
               <p:cNvPr id="8" name="TextBox 7"/>
@@ -14988,7 +14993,7 @@
             </p:txBody>
           </p:sp>
         </mc:Choice>
-        <mc:Fallback>
+        <mc:Fallback xmlns="">
           <p:sp>
             <p:nvSpPr>
               <p:cNvPr id="8" name="TextBox 7"/>
@@ -15027,8 +15032,8 @@
           </p:sp>
         </mc:Fallback>
       </mc:AlternateContent>
-      <mc:AlternateContent xmlns:mc="http://schemas.openxmlformats.org/markup-compatibility/2006">
-        <mc:Choice xmlns:a14="http://schemas.microsoft.com/office/drawing/2010/main" Requires="a14">
+      <mc:AlternateContent xmlns:mc="http://schemas.openxmlformats.org/markup-compatibility/2006" xmlns:a14="http://schemas.microsoft.com/office/drawing/2010/main">
+        <mc:Choice Requires="a14">
           <p:sp>
             <p:nvSpPr>
               <p:cNvPr id="9" name="TextBox 8"/>
@@ -15114,7 +15119,7 @@
             </p:txBody>
           </p:sp>
         </mc:Choice>
-        <mc:Fallback>
+        <mc:Fallback xmlns="">
           <p:sp>
             <p:nvSpPr>
               <p:cNvPr id="9" name="TextBox 8"/>
@@ -15195,8 +15200,8 @@
           </a:p>
         </p:txBody>
       </p:sp>
-      <mc:AlternateContent xmlns:mc="http://schemas.openxmlformats.org/markup-compatibility/2006">
-        <mc:Choice xmlns:a14="http://schemas.microsoft.com/office/drawing/2010/main" Requires="a14">
+      <mc:AlternateContent xmlns:mc="http://schemas.openxmlformats.org/markup-compatibility/2006" xmlns:a14="http://schemas.microsoft.com/office/drawing/2010/main">
+        <mc:Choice Requires="a14">
           <p:graphicFrame>
             <p:nvGraphicFramePr>
               <p:cNvPr id="11" name="Table 10"/>
@@ -15790,7 +15795,7 @@
             </a:graphic>
           </p:graphicFrame>
         </mc:Choice>
-        <mc:Fallback>
+        <mc:Fallback xmlns="">
           <p:graphicFrame>
             <p:nvGraphicFramePr>
               <p:cNvPr id="11" name="Table 10"/>
@@ -16443,8 +16448,8 @@
           </a:p>
         </p:txBody>
       </p:sp>
-      <mc:AlternateContent xmlns:mc="http://schemas.openxmlformats.org/markup-compatibility/2006">
-        <mc:Choice xmlns:a14="http://schemas.microsoft.com/office/drawing/2010/main" Requires="a14">
+      <mc:AlternateContent xmlns:mc="http://schemas.openxmlformats.org/markup-compatibility/2006" xmlns:a14="http://schemas.microsoft.com/office/drawing/2010/main">
+        <mc:Choice Requires="a14">
           <p:sp>
             <p:nvSpPr>
               <p:cNvPr id="14" name="TextBox 13"/>
@@ -16586,7 +16591,7 @@
             </p:txBody>
           </p:sp>
         </mc:Choice>
-        <mc:Fallback>
+        <mc:Fallback xmlns="">
           <p:sp>
             <p:nvSpPr>
               <p:cNvPr id="14" name="TextBox 13"/>
@@ -17089,8 +17094,8 @@
           </a:p>
         </p:txBody>
       </p:sp>
-      <mc:AlternateContent xmlns:mc="http://schemas.openxmlformats.org/markup-compatibility/2006">
-        <mc:Choice xmlns:a14="http://schemas.microsoft.com/office/drawing/2010/main" Requires="a14">
+      <mc:AlternateContent xmlns:mc="http://schemas.openxmlformats.org/markup-compatibility/2006" xmlns:a14="http://schemas.microsoft.com/office/drawing/2010/main">
+        <mc:Choice Requires="a14">
           <p:sp>
             <p:nvSpPr>
               <p:cNvPr id="9" name="TextBox 8"/>
@@ -17372,7 +17377,7 @@
             </p:txBody>
           </p:sp>
         </mc:Choice>
-        <mc:Fallback>
+        <mc:Fallback xmlns="">
           <p:sp>
             <p:nvSpPr>
               <p:cNvPr id="9" name="TextBox 8"/>
@@ -17495,8 +17500,8 @@
           </a:p>
         </p:txBody>
       </p:sp>
-      <mc:AlternateContent xmlns:mc="http://schemas.openxmlformats.org/markup-compatibility/2006">
-        <mc:Choice xmlns:a14="http://schemas.microsoft.com/office/drawing/2010/main" Requires="a14">
+      <mc:AlternateContent xmlns:mc="http://schemas.openxmlformats.org/markup-compatibility/2006" xmlns:a14="http://schemas.microsoft.com/office/drawing/2010/main">
+        <mc:Choice Requires="a14">
           <p:graphicFrame>
             <p:nvGraphicFramePr>
               <p:cNvPr id="12" name="Table 11"/>
@@ -17999,7 +18004,7 @@
             </a:graphic>
           </p:graphicFrame>
         </mc:Choice>
-        <mc:Fallback>
+        <mc:Fallback xmlns="">
           <p:graphicFrame>
             <p:nvGraphicFramePr>
               <p:cNvPr id="12" name="Table 11"/>

</xml_diff>